<commit_message>
presentación con el link del repo
</commit_message>
<xml_diff>
--- a/Pronóstico de Demanda Eléctrica GBA.pptx
+++ b/Pronóstico de Demanda Eléctrica GBA.pptx
@@ -500,7 +500,7 @@
         <p:spPr>
           <a:xfrm>
             <a:off x="6573097" y="3683134"/>
-            <a:ext cx="6934346" cy="1217243"/>
+            <a:ext cx="6934346" cy="1217244"/>
           </a:xfrm>
           <a:prstGeom prst="rect">
             <a:avLst/>
@@ -538,7 +538,7 @@
         <p:spPr>
           <a:xfrm>
             <a:off x="6466985" y="3362850"/>
-            <a:ext cx="6955792" cy="1478282"/>
+            <a:ext cx="6955792" cy="1478283"/>
           </a:xfrm>
           <a:prstGeom prst="rect">
             <a:avLst/>
@@ -566,7 +566,7 @@
         <p:spPr>
           <a:xfrm>
             <a:off x="3015613" y="6333235"/>
-            <a:ext cx="14072873" cy="2827340"/>
+            <a:ext cx="14072873" cy="2827341"/>
           </a:xfrm>
           <a:prstGeom prst="rect">
             <a:avLst/>
@@ -690,7 +690,7 @@
         <p:spPr>
           <a:xfrm>
             <a:off x="10366175" y="3376860"/>
-            <a:ext cx="8458201" cy="5505453"/>
+            <a:ext cx="8458201" cy="5505454"/>
           </a:xfrm>
           <a:prstGeom prst="rect">
             <a:avLst/>
@@ -814,7 +814,7 @@
         <p:spPr>
           <a:xfrm>
             <a:off x="10366175" y="3376860"/>
-            <a:ext cx="8458201" cy="5505453"/>
+            <a:ext cx="8458201" cy="5505454"/>
           </a:xfrm>
           <a:prstGeom prst="rect">
             <a:avLst/>
@@ -1161,7 +1161,7 @@
         <p:spPr>
           <a:xfrm>
             <a:off x="912419" y="535057"/>
-            <a:ext cx="10010769" cy="1026797"/>
+            <a:ext cx="10010769" cy="1026798"/>
           </a:xfrm>
           <a:prstGeom prst="rect">
             <a:avLst/>
@@ -2088,8 +2088,8 @@
         </p:nvSpPr>
         <p:spPr>
           <a:xfrm>
-            <a:off x="1900150" y="2548083"/>
-            <a:ext cx="16188694" cy="1419864"/>
+            <a:off x="1900149" y="2548083"/>
+            <a:ext cx="16188695" cy="1419865"/>
           </a:xfrm>
           <a:prstGeom prst="rect">
             <a:avLst/>
@@ -2099,7 +2099,7 @@
           <a:bodyPr/>
           <a:lstStyle/>
           <a:p>
-            <a:pPr indent="11427" defTabSz="822958">
+            <a:pPr indent="11426" defTabSz="822958">
               <a:defRPr spc="-100" sz="8100">
                 <a:latin typeface="Avenir Book"/>
                 <a:ea typeface="Avenir Book"/>
@@ -2158,7 +2158,7 @@
         <p:spPr>
           <a:xfrm>
             <a:off x="15705" y="4256413"/>
-            <a:ext cx="20080542" cy="824586"/>
+            <a:ext cx="20080542" cy="824587"/>
           </a:xfrm>
           <a:prstGeom prst="rect">
             <a:avLst/>
@@ -2245,7 +2245,7 @@
         <p:spPr>
           <a:xfrm>
             <a:off x="15705" y="5748516"/>
-            <a:ext cx="20080542" cy="337689"/>
+            <a:ext cx="20080542" cy="337690"/>
           </a:xfrm>
           <a:prstGeom prst="rect">
             <a:avLst/>
@@ -2549,7 +2549,7 @@
         <p:spPr>
           <a:xfrm>
             <a:off x="11557337" y="7593372"/>
-            <a:ext cx="3427608" cy="1289286"/>
+            <a:ext cx="3427609" cy="1289287"/>
           </a:xfrm>
           <a:prstGeom prst="rect">
             <a:avLst/>
@@ -2559,6 +2559,68 @@
           </a:ln>
         </p:spPr>
       </p:pic>
+      <p:sp>
+        <p:nvSpPr>
+          <p:cNvPr id="72" name="Link al repositorio"/>
+          <p:cNvSpPr txBox="1"/>
+          <p:nvPr/>
+        </p:nvSpPr>
+        <p:spPr>
+          <a:xfrm>
+            <a:off x="8396399" y="9743502"/>
+            <a:ext cx="2959223" cy="364436"/>
+          </a:xfrm>
+          <a:prstGeom prst="rect">
+            <a:avLst/>
+          </a:prstGeom>
+          <a:ln w="12700">
+            <a:miter lim="400000"/>
+          </a:ln>
+          <a:extLst>
+            <a:ext uri="{C572A759-6A51-4108-AA02-DFA0A04FC94B}">
+              <ma14:wrappingTextBoxFlag xmlns:ma14="http://schemas.microsoft.com/office/mac/drawingml/2011/main" val="1"/>
+            </a:ext>
+          </a:extLst>
+        </p:spPr>
+        <p:txBody>
+          <a:bodyPr lIns="45718" tIns="45718" rIns="45718" bIns="45718">
+            <a:spAutoFit/>
+          </a:bodyPr>
+          <a:lstStyle>
+            <a:lvl1pPr algn="ctr">
+              <a:defRPr u="sng">
+                <a:solidFill>
+                  <a:srgbClr val="FF40FF"/>
+                </a:solidFill>
+                <a:uFill>
+                  <a:solidFill>
+                    <a:srgbClr val="0000FF"/>
+                  </a:solidFill>
+                </a:uFill>
+                <a:hlinkClick r:id="rId3" invalidUrl="" action="" tgtFrame="" tooltip="" history="1" highlightClick="0" endSnd="0"/>
+              </a:defRPr>
+            </a:lvl1pPr>
+          </a:lstStyle>
+          <a:p>
+            <a:pPr>
+              <a:defRPr u="none">
+                <a:uFillTx/>
+              </a:defRPr>
+            </a:pPr>
+            <a:r>
+              <a:rPr u="sng">
+                <a:uFill>
+                  <a:solidFill>
+                    <a:srgbClr val="0000FF"/>
+                  </a:solidFill>
+                </a:uFill>
+                <a:hlinkClick r:id="rId3" invalidUrl="" action="" tgtFrame="" tooltip="" history="1" highlightClick="0" endSnd="0"/>
+              </a:rPr>
+              <a:t>Link al repositorio</a:t>
+            </a:r>
+          </a:p>
+        </p:txBody>
+      </p:sp>
     </p:spTree>
   </p:cSld>
   <p:clrMapOvr>
@@ -2594,14 +2656,14 @@
       </p:grpSpPr>
       <p:sp>
         <p:nvSpPr>
-          <p:cNvPr id="138" name="object 8"/>
+          <p:cNvPr id="139" name="object 8"/>
           <p:cNvSpPr/>
           <p:nvPr/>
         </p:nvSpPr>
         <p:spPr>
           <a:xfrm>
             <a:off x="15705" y="769608"/>
-            <a:ext cx="20080542" cy="636110"/>
+            <a:ext cx="20080542" cy="636111"/>
           </a:xfrm>
           <a:prstGeom prst="rect">
             <a:avLst/>
@@ -2630,7 +2692,7 @@
       </p:sp>
       <p:sp>
         <p:nvSpPr>
-          <p:cNvPr id="139" name="object 9"/>
+          <p:cNvPr id="140" name="object 9"/>
           <p:cNvSpPr txBox="1"/>
           <p:nvPr>
             <p:ph type="title"/>
@@ -2693,14 +2755,14 @@
       </p:sp>
       <p:sp>
         <p:nvSpPr>
-          <p:cNvPr id="140" name="object 10"/>
+          <p:cNvPr id="141" name="object 10"/>
           <p:cNvSpPr txBox="1"/>
           <p:nvPr/>
         </p:nvSpPr>
         <p:spPr>
           <a:xfrm>
             <a:off x="10930983" y="2561464"/>
-            <a:ext cx="8458203" cy="4832549"/>
+            <a:ext cx="8458204" cy="4832549"/>
           </a:xfrm>
           <a:prstGeom prst="rect">
             <a:avLst/>
@@ -3054,7 +3116,7 @@
       </p:sp>
       <p:pic>
         <p:nvPicPr>
-          <p:cNvPr id="141" name="Screenshot 2026-06-15 at 2.21.56 PM.png" descr="Screenshot 2026-06-15 at 2.21.56 PM.png"/>
+          <p:cNvPr id="142" name="Screenshot 2026-06-15 at 2.21.56 PM.png" descr="Screenshot 2026-06-15 at 2.21.56 PM.png"/>
           <p:cNvPicPr>
             <a:picLocks noChangeAspect="1"/>
           </p:cNvPicPr>
@@ -3071,7 +3133,7 @@
         <p:spPr>
           <a:xfrm>
             <a:off x="692352" y="2225793"/>
-            <a:ext cx="10130654" cy="7965984"/>
+            <a:ext cx="10130654" cy="7965985"/>
           </a:xfrm>
           <a:prstGeom prst="rect">
             <a:avLst/>
@@ -3116,7 +3178,7 @@
       </p:grpSpPr>
       <p:sp>
         <p:nvSpPr>
-          <p:cNvPr id="143" name="object 2"/>
+          <p:cNvPr id="144" name="object 2"/>
           <p:cNvSpPr txBox="1"/>
           <p:nvPr>
             <p:ph type="ctrTitle"/>
@@ -3125,7 +3187,7 @@
         <p:spPr>
           <a:xfrm>
             <a:off x="6466985" y="3362850"/>
-            <a:ext cx="6955792" cy="1478282"/>
+            <a:ext cx="6955792" cy="1478283"/>
           </a:xfrm>
           <a:prstGeom prst="rect">
             <a:avLst/>
@@ -3151,14 +3213,14 @@
       </p:sp>
       <p:sp>
         <p:nvSpPr>
-          <p:cNvPr id="144" name="object 3"/>
+          <p:cNvPr id="145" name="object 3"/>
           <p:cNvSpPr/>
           <p:nvPr/>
         </p:nvSpPr>
         <p:spPr>
           <a:xfrm>
             <a:off x="6109761" y="5324445"/>
-            <a:ext cx="7892431" cy="306277"/>
+            <a:ext cx="7892431" cy="306278"/>
           </a:xfrm>
           <a:prstGeom prst="rect">
             <a:avLst/>
@@ -3187,7 +3249,7 @@
       </p:sp>
       <p:sp>
         <p:nvSpPr>
-          <p:cNvPr id="145" name="object 4"/>
+          <p:cNvPr id="146" name="object 4"/>
           <p:cNvSpPr txBox="1"/>
           <p:nvPr/>
         </p:nvSpPr>
@@ -3393,14 +3455,14 @@
       </p:grpSpPr>
       <p:sp>
         <p:nvSpPr>
-          <p:cNvPr id="73" name="object 8"/>
+          <p:cNvPr id="74" name="object 8"/>
           <p:cNvSpPr/>
           <p:nvPr/>
         </p:nvSpPr>
         <p:spPr>
           <a:xfrm>
             <a:off x="15705" y="816729"/>
-            <a:ext cx="20080542" cy="777466"/>
+            <a:ext cx="20080542" cy="777467"/>
           </a:xfrm>
           <a:prstGeom prst="rect">
             <a:avLst/>
@@ -3429,7 +3491,7 @@
       </p:sp>
       <p:sp>
         <p:nvSpPr>
-          <p:cNvPr id="74" name="object 9"/>
+          <p:cNvPr id="75" name="object 9"/>
           <p:cNvSpPr txBox="1"/>
           <p:nvPr>
             <p:ph type="title"/>
@@ -3448,7 +3510,7 @@
           <a:bodyPr/>
           <a:lstStyle/>
           <a:p>
-            <a:pPr indent="12266" defTabSz="841247">
+            <a:pPr indent="12265" defTabSz="841247">
               <a:defRPr spc="-100" sz="5800">
                 <a:latin typeface="Avenir Book"/>
                 <a:ea typeface="Avenir Book"/>
@@ -3484,7 +3546,7 @@
       </p:sp>
       <p:sp>
         <p:nvSpPr>
-          <p:cNvPr id="75" name="object 16"/>
+          <p:cNvPr id="76" name="object 16"/>
           <p:cNvSpPr txBox="1"/>
           <p:nvPr/>
         </p:nvSpPr>
@@ -4068,7 +4130,7 @@
       </p:sp>
       <p:pic>
         <p:nvPicPr>
-          <p:cNvPr id="76" name="Screenshot 2026-06-15 at 2.20.27 PM.png" descr="Screenshot 2026-06-15 at 2.20.27 PM.png"/>
+          <p:cNvPr id="77" name="Screenshot 2026-06-15 at 2.20.27 PM.png" descr="Screenshot 2026-06-15 at 2.20.27 PM.png"/>
           <p:cNvPicPr>
             <a:picLocks noChangeAspect="1"/>
           </p:cNvPicPr>
@@ -4130,14 +4192,14 @@
       </p:grpSpPr>
       <p:sp>
         <p:nvSpPr>
-          <p:cNvPr id="78" name="object 8"/>
+          <p:cNvPr id="79" name="object 8"/>
           <p:cNvSpPr/>
           <p:nvPr/>
         </p:nvSpPr>
         <p:spPr>
           <a:xfrm>
             <a:off x="15705" y="769608"/>
-            <a:ext cx="20080542" cy="636110"/>
+            <a:ext cx="20080542" cy="636111"/>
           </a:xfrm>
           <a:prstGeom prst="rect">
             <a:avLst/>
@@ -4166,7 +4228,7 @@
       </p:sp>
       <p:sp>
         <p:nvSpPr>
-          <p:cNvPr id="79" name="object 9"/>
+          <p:cNvPr id="80" name="object 9"/>
           <p:cNvSpPr txBox="1"/>
           <p:nvPr>
             <p:ph type="title"/>
@@ -4185,7 +4247,7 @@
           <a:bodyPr/>
           <a:lstStyle/>
           <a:p>
-            <a:pPr indent="12266" defTabSz="841247">
+            <a:pPr indent="12265" defTabSz="841247">
               <a:defRPr spc="-200" sz="5800">
                 <a:latin typeface="Avenir Book"/>
                 <a:ea typeface="Avenir Book"/>
@@ -4217,14 +4279,14 @@
       </p:sp>
       <p:sp>
         <p:nvSpPr>
-          <p:cNvPr id="80" name="object 10"/>
+          <p:cNvPr id="81" name="object 10"/>
           <p:cNvSpPr txBox="1"/>
           <p:nvPr/>
         </p:nvSpPr>
         <p:spPr>
           <a:xfrm>
-            <a:off x="11694237" y="2750990"/>
-            <a:ext cx="8143878" cy="4612743"/>
+            <a:off x="11694237" y="2750989"/>
+            <a:ext cx="8143879" cy="4612743"/>
           </a:xfrm>
           <a:prstGeom prst="rect">
             <a:avLst/>
@@ -4647,7 +4709,7 @@
       </p:sp>
       <p:pic>
         <p:nvPicPr>
-          <p:cNvPr id="81" name="Screenshot 2026-06-15 at 2.20.05 PM.png" descr="Screenshot 2026-06-15 at 2.20.05 PM.png"/>
+          <p:cNvPr id="82" name="Screenshot 2026-06-15 at 2.20.05 PM.png" descr="Screenshot 2026-06-15 at 2.20.05 PM.png"/>
           <p:cNvPicPr>
             <a:picLocks noChangeAspect="1"/>
           </p:cNvPicPr>
@@ -4709,7 +4771,7 @@
       </p:grpSpPr>
       <p:sp>
         <p:nvSpPr>
-          <p:cNvPr id="83" name="object 2"/>
+          <p:cNvPr id="84" name="object 2"/>
           <p:cNvSpPr/>
           <p:nvPr/>
         </p:nvSpPr>
@@ -4745,7 +4807,7 @@
       </p:sp>
       <p:sp>
         <p:nvSpPr>
-          <p:cNvPr id="84" name="object 3"/>
+          <p:cNvPr id="85" name="object 3"/>
           <p:cNvSpPr txBox="1"/>
           <p:nvPr>
             <p:ph type="title"/>
@@ -4792,7 +4854,7 @@
       </p:sp>
       <p:sp>
         <p:nvSpPr>
-          <p:cNvPr id="85" name="object 5"/>
+          <p:cNvPr id="86" name="object 5"/>
           <p:cNvSpPr txBox="1"/>
           <p:nvPr/>
         </p:nvSpPr>
@@ -4843,14 +4905,14 @@
       </p:sp>
       <p:sp>
         <p:nvSpPr>
-          <p:cNvPr id="86" name="object 6"/>
+          <p:cNvPr id="87" name="object 6"/>
           <p:cNvSpPr txBox="1"/>
           <p:nvPr/>
         </p:nvSpPr>
         <p:spPr>
           <a:xfrm>
             <a:off x="1298655" y="2711298"/>
-            <a:ext cx="4751710" cy="1476909"/>
+            <a:ext cx="4751711" cy="1476909"/>
           </a:xfrm>
           <a:prstGeom prst="rect">
             <a:avLst/>
@@ -4870,7 +4932,7 @@
           </a:bodyPr>
           <a:lstStyle/>
           <a:p>
-            <a:pPr marR="5080" indent="12063" algn="just">
+            <a:pPr marR="5080" indent="12062" algn="just">
               <a:lnSpc>
                 <a:spcPct val="126200"/>
               </a:lnSpc>
@@ -5083,7 +5145,7 @@
       </p:sp>
       <p:sp>
         <p:nvSpPr>
-          <p:cNvPr id="87" name="object 7"/>
+          <p:cNvPr id="88" name="object 7"/>
           <p:cNvSpPr txBox="1"/>
           <p:nvPr/>
         </p:nvSpPr>
@@ -5134,14 +5196,14 @@
       </p:sp>
       <p:sp>
         <p:nvSpPr>
-          <p:cNvPr id="88" name="object 8"/>
+          <p:cNvPr id="89" name="object 8"/>
           <p:cNvSpPr txBox="1"/>
           <p:nvPr/>
         </p:nvSpPr>
         <p:spPr>
           <a:xfrm>
-            <a:off x="1655356" y="5862823"/>
-            <a:ext cx="4546604" cy="1545972"/>
+            <a:off x="1655355" y="5862823"/>
+            <a:ext cx="4546605" cy="1545972"/>
           </a:xfrm>
           <a:prstGeom prst="rect">
             <a:avLst/>
@@ -5325,14 +5387,14 @@
       </p:sp>
       <p:sp>
         <p:nvSpPr>
-          <p:cNvPr id="89" name="object 9"/>
+          <p:cNvPr id="90" name="object 9"/>
           <p:cNvSpPr txBox="1"/>
           <p:nvPr/>
         </p:nvSpPr>
         <p:spPr>
           <a:xfrm>
             <a:off x="1717173" y="8107298"/>
-            <a:ext cx="1392136" cy="482601"/>
+            <a:ext cx="1392137" cy="482601"/>
           </a:xfrm>
           <a:prstGeom prst="rect">
             <a:avLst/>
@@ -5376,14 +5438,14 @@
       </p:sp>
       <p:sp>
         <p:nvSpPr>
-          <p:cNvPr id="90" name="object 10"/>
+          <p:cNvPr id="91" name="object 10"/>
           <p:cNvSpPr txBox="1"/>
           <p:nvPr/>
         </p:nvSpPr>
         <p:spPr>
           <a:xfrm>
             <a:off x="1710133" y="8802458"/>
-            <a:ext cx="4129977" cy="1478484"/>
+            <a:ext cx="4129978" cy="1478484"/>
           </a:xfrm>
           <a:prstGeom prst="rect">
             <a:avLst/>
@@ -5403,7 +5465,7 @@
           </a:bodyPr>
           <a:lstStyle/>
           <a:p>
-            <a:pPr marR="5080" indent="12062">
+            <a:pPr marR="5080" indent="12061">
               <a:lnSpc>
                 <a:spcPct val="121200"/>
               </a:lnSpc>
@@ -5565,14 +5627,14 @@
       </p:sp>
       <p:sp>
         <p:nvSpPr>
-          <p:cNvPr id="91" name="Shape"/>
+          <p:cNvPr id="92" name="Shape"/>
           <p:cNvSpPr/>
           <p:nvPr/>
         </p:nvSpPr>
         <p:spPr>
           <a:xfrm>
-            <a:off x="912417" y="1625074"/>
-            <a:ext cx="5524185" cy="2795701"/>
+            <a:off x="912416" y="1625073"/>
+            <a:ext cx="5524186" cy="2795703"/>
           </a:xfrm>
           <a:custGeom>
             <a:avLst/>
@@ -5764,14 +5826,14 @@
       </p:sp>
       <p:sp>
         <p:nvSpPr>
-          <p:cNvPr id="92" name="Shape"/>
+          <p:cNvPr id="93" name="Shape"/>
           <p:cNvSpPr/>
           <p:nvPr/>
         </p:nvSpPr>
         <p:spPr>
           <a:xfrm>
-            <a:off x="912417" y="4817243"/>
-            <a:ext cx="5524185" cy="2661020"/>
+            <a:off x="912416" y="4817243"/>
+            <a:ext cx="5524186" cy="2661020"/>
           </a:xfrm>
           <a:custGeom>
             <a:avLst/>
@@ -5963,14 +6025,14 @@
       </p:sp>
       <p:sp>
         <p:nvSpPr>
-          <p:cNvPr id="93" name="Shape"/>
+          <p:cNvPr id="94" name="Shape"/>
           <p:cNvSpPr/>
           <p:nvPr/>
         </p:nvSpPr>
         <p:spPr>
           <a:xfrm>
-            <a:off x="918768" y="7875871"/>
-            <a:ext cx="5511485" cy="2819795"/>
+            <a:off x="918767" y="7875871"/>
+            <a:ext cx="5511486" cy="2819796"/>
           </a:xfrm>
           <a:custGeom>
             <a:avLst/>
@@ -6162,7 +6224,7 @@
       </p:sp>
       <p:pic>
         <p:nvPicPr>
-          <p:cNvPr id="94" name="Imagen 2" descr="Imagen 2"/>
+          <p:cNvPr id="95" name="Imagen 2" descr="Imagen 2"/>
           <p:cNvPicPr>
             <a:picLocks noChangeAspect="1"/>
           </p:cNvPicPr>
@@ -6179,7 +6241,7 @@
         <p:spPr>
           <a:xfrm>
             <a:off x="7228654" y="1740311"/>
-            <a:ext cx="12094775" cy="8570757"/>
+            <a:ext cx="12094776" cy="8570757"/>
           </a:xfrm>
           <a:prstGeom prst="rect">
             <a:avLst/>
@@ -6224,7 +6286,7 @@
       </p:grpSpPr>
       <p:sp>
         <p:nvSpPr>
-          <p:cNvPr id="96" name="object 8"/>
+          <p:cNvPr id="97" name="object 8"/>
           <p:cNvSpPr/>
           <p:nvPr/>
         </p:nvSpPr>
@@ -6260,7 +6322,7 @@
       </p:sp>
       <p:sp>
         <p:nvSpPr>
-          <p:cNvPr id="97" name="object 9"/>
+          <p:cNvPr id="98" name="object 9"/>
           <p:cNvSpPr txBox="1"/>
           <p:nvPr>
             <p:ph type="title"/>
@@ -6311,7 +6373,7 @@
       </p:sp>
       <p:sp>
         <p:nvSpPr>
-          <p:cNvPr id="98" name="object 10"/>
+          <p:cNvPr id="99" name="object 10"/>
           <p:cNvSpPr txBox="1"/>
           <p:nvPr/>
         </p:nvSpPr>
@@ -6981,7 +7043,7 @@
       </p:sp>
       <p:pic>
         <p:nvPicPr>
-          <p:cNvPr id="99" name="Screenshot 2026-06-15 at 2.21.07 PM.png" descr="Screenshot 2026-06-15 at 2.21.07 PM.png"/>
+          <p:cNvPr id="100" name="Screenshot 2026-06-15 at 2.21.07 PM.png" descr="Screenshot 2026-06-15 at 2.21.07 PM.png"/>
           <p:cNvPicPr>
             <a:picLocks noChangeAspect="1"/>
           </p:cNvPicPr>
@@ -7043,14 +7105,14 @@
       </p:grpSpPr>
       <p:sp>
         <p:nvSpPr>
-          <p:cNvPr id="101" name="object 2"/>
+          <p:cNvPr id="102" name="object 2"/>
           <p:cNvSpPr/>
           <p:nvPr/>
         </p:nvSpPr>
         <p:spPr>
           <a:xfrm>
             <a:off x="15705" y="2340242"/>
-            <a:ext cx="20080542" cy="636110"/>
+            <a:ext cx="20080542" cy="636111"/>
           </a:xfrm>
           <a:prstGeom prst="rect">
             <a:avLst/>
@@ -7079,7 +7141,7 @@
       </p:sp>
       <p:sp>
         <p:nvSpPr>
-          <p:cNvPr id="102" name="object 3"/>
+          <p:cNvPr id="103" name="object 3"/>
           <p:cNvSpPr txBox="1"/>
           <p:nvPr>
             <p:ph type="title"/>
@@ -7088,7 +7150,7 @@
         <p:spPr>
           <a:xfrm>
             <a:off x="906721" y="2105690"/>
-            <a:ext cx="8140066" cy="1026797"/>
+            <a:ext cx="8140066" cy="1026798"/>
           </a:xfrm>
           <a:prstGeom prst="rect">
             <a:avLst/>
@@ -7133,21 +7195,21 @@
       </p:sp>
       <p:grpSp>
         <p:nvGrpSpPr>
-          <p:cNvPr id="105" name="object 14"/>
+          <p:cNvPr id="106" name="object 14"/>
           <p:cNvGrpSpPr/>
           <p:nvPr/>
         </p:nvGrpSpPr>
         <p:grpSpPr>
           <a:xfrm>
-            <a:off x="15703" y="5497214"/>
-            <a:ext cx="20080549" cy="494754"/>
-            <a:chOff x="0" y="0"/>
-            <a:chExt cx="20080547" cy="494752"/>
+            <a:off x="15702" y="5497213"/>
+            <a:ext cx="20080552" cy="494757"/>
+            <a:chOff x="0" y="-1"/>
+            <a:chExt cx="20080551" cy="494755"/>
           </a:xfrm>
         </p:grpSpPr>
         <p:pic>
           <p:nvPicPr>
-            <p:cNvPr id="103" name="object 15" descr="object 15"/>
+            <p:cNvPr id="104" name="object 15" descr="object 15"/>
             <p:cNvPicPr>
               <a:picLocks noChangeAspect="1"/>
             </p:cNvPicPr>
@@ -7164,7 +7226,7 @@
           <p:spPr>
             <a:xfrm>
               <a:off x="6266826" y="15706"/>
-              <a:ext cx="5465806" cy="471194"/>
+              <a:ext cx="5465808" cy="471196"/>
             </a:xfrm>
             <a:prstGeom prst="rect">
               <a:avLst/>
@@ -7178,14 +7240,14 @@
         </p:pic>
         <p:sp>
           <p:nvSpPr>
-            <p:cNvPr id="104" name="object 16"/>
+            <p:cNvPr id="105" name="object 16"/>
             <p:cNvSpPr/>
             <p:nvPr/>
           </p:nvSpPr>
           <p:spPr>
             <a:xfrm>
-              <a:off x="-1" y="-1"/>
-              <a:ext cx="20080549" cy="494754"/>
+              <a:off x="-1" y="-2"/>
+              <a:ext cx="20080552" cy="494757"/>
             </a:xfrm>
             <a:prstGeom prst="rect">
               <a:avLst/>
@@ -7219,14 +7281,14 @@
       </p:grpSp>
       <p:sp>
         <p:nvSpPr>
-          <p:cNvPr id="106" name="object 19"/>
+          <p:cNvPr id="107" name="object 19"/>
           <p:cNvSpPr/>
           <p:nvPr/>
         </p:nvSpPr>
         <p:spPr>
           <a:xfrm>
             <a:off x="15705" y="7020728"/>
-            <a:ext cx="20080542" cy="337689"/>
+            <a:ext cx="20080542" cy="337690"/>
           </a:xfrm>
           <a:prstGeom prst="rect">
             <a:avLst/>
@@ -7255,14 +7317,14 @@
       </p:sp>
       <p:sp>
         <p:nvSpPr>
-          <p:cNvPr id="107" name="object 20"/>
+          <p:cNvPr id="108" name="object 20"/>
           <p:cNvSpPr/>
           <p:nvPr/>
         </p:nvSpPr>
         <p:spPr>
           <a:xfrm>
             <a:off x="15705" y="7491917"/>
-            <a:ext cx="20080542" cy="337689"/>
+            <a:ext cx="20080542" cy="337690"/>
           </a:xfrm>
           <a:prstGeom prst="rect">
             <a:avLst/>
@@ -7291,7 +7353,7 @@
       </p:sp>
       <p:sp>
         <p:nvSpPr>
-          <p:cNvPr id="108" name="object 21"/>
+          <p:cNvPr id="109" name="object 21"/>
           <p:cNvSpPr txBox="1"/>
           <p:nvPr/>
         </p:nvSpPr>
@@ -7525,7 +7587,7 @@
       </p:sp>
       <p:pic>
         <p:nvPicPr>
-          <p:cNvPr id="109" name="Screenshot 2026-06-15 at 2.42.22 PM.png" descr="Screenshot 2026-06-15 at 2.42.22 PM.png"/>
+          <p:cNvPr id="110" name="Screenshot 2026-06-15 at 2.42.22 PM.png" descr="Screenshot 2026-06-15 at 2.42.22 PM.png"/>
           <p:cNvPicPr>
             <a:picLocks noChangeAspect="1"/>
           </p:cNvPicPr>
@@ -7587,14 +7649,14 @@
       </p:grpSpPr>
       <p:sp>
         <p:nvSpPr>
-          <p:cNvPr id="111" name="object 2"/>
+          <p:cNvPr id="112" name="object 2"/>
           <p:cNvSpPr/>
           <p:nvPr/>
         </p:nvSpPr>
         <p:spPr>
           <a:xfrm>
             <a:off x="15705" y="2340242"/>
-            <a:ext cx="20080542" cy="636110"/>
+            <a:ext cx="20080542" cy="636111"/>
           </a:xfrm>
           <a:prstGeom prst="rect">
             <a:avLst/>
@@ -7623,7 +7685,7 @@
       </p:sp>
       <p:sp>
         <p:nvSpPr>
-          <p:cNvPr id="112" name="object 3"/>
+          <p:cNvPr id="113" name="object 3"/>
           <p:cNvSpPr txBox="1"/>
           <p:nvPr>
             <p:ph type="title"/>
@@ -7632,7 +7694,7 @@
         <p:spPr>
           <a:xfrm>
             <a:off x="975994" y="1179945"/>
-            <a:ext cx="8140066" cy="1026797"/>
+            <a:ext cx="8140066" cy="1026798"/>
           </a:xfrm>
           <a:prstGeom prst="rect">
             <a:avLst/>
@@ -7677,21 +7739,21 @@
       </p:sp>
       <p:grpSp>
         <p:nvGrpSpPr>
-          <p:cNvPr id="115" name="object 14"/>
+          <p:cNvPr id="116" name="object 14"/>
           <p:cNvGrpSpPr/>
           <p:nvPr/>
         </p:nvGrpSpPr>
         <p:grpSpPr>
           <a:xfrm>
-            <a:off x="15703" y="5497214"/>
-            <a:ext cx="20080549" cy="494754"/>
-            <a:chOff x="0" y="0"/>
-            <a:chExt cx="20080547" cy="494752"/>
+            <a:off x="15702" y="5497213"/>
+            <a:ext cx="20080552" cy="494757"/>
+            <a:chOff x="0" y="-1"/>
+            <a:chExt cx="20080551" cy="494755"/>
           </a:xfrm>
         </p:grpSpPr>
         <p:pic>
           <p:nvPicPr>
-            <p:cNvPr id="113" name="object 15" descr="object 15"/>
+            <p:cNvPr id="114" name="object 15" descr="object 15"/>
             <p:cNvPicPr>
               <a:picLocks noChangeAspect="1"/>
             </p:cNvPicPr>
@@ -7708,7 +7770,7 @@
           <p:spPr>
             <a:xfrm>
               <a:off x="6266826" y="15706"/>
-              <a:ext cx="5465806" cy="471194"/>
+              <a:ext cx="5465808" cy="471196"/>
             </a:xfrm>
             <a:prstGeom prst="rect">
               <a:avLst/>
@@ -7722,14 +7784,14 @@
         </p:pic>
         <p:sp>
           <p:nvSpPr>
-            <p:cNvPr id="114" name="object 16"/>
+            <p:cNvPr id="115" name="object 16"/>
             <p:cNvSpPr/>
             <p:nvPr/>
           </p:nvSpPr>
           <p:spPr>
             <a:xfrm>
-              <a:off x="-1" y="-1"/>
-              <a:ext cx="20080549" cy="494754"/>
+              <a:off x="-1" y="-2"/>
+              <a:ext cx="20080552" cy="494757"/>
             </a:xfrm>
             <a:prstGeom prst="rect">
               <a:avLst/>
@@ -7763,14 +7825,14 @@
       </p:grpSp>
       <p:sp>
         <p:nvSpPr>
-          <p:cNvPr id="116" name="object 19"/>
+          <p:cNvPr id="117" name="object 19"/>
           <p:cNvSpPr/>
           <p:nvPr/>
         </p:nvSpPr>
         <p:spPr>
           <a:xfrm>
             <a:off x="15705" y="7020728"/>
-            <a:ext cx="20080542" cy="337689"/>
+            <a:ext cx="20080542" cy="337690"/>
           </a:xfrm>
           <a:prstGeom prst="rect">
             <a:avLst/>
@@ -7799,14 +7861,14 @@
       </p:sp>
       <p:sp>
         <p:nvSpPr>
-          <p:cNvPr id="117" name="object 20"/>
+          <p:cNvPr id="118" name="object 20"/>
           <p:cNvSpPr/>
           <p:nvPr/>
         </p:nvSpPr>
         <p:spPr>
           <a:xfrm>
             <a:off x="15705" y="7491917"/>
-            <a:ext cx="20080542" cy="337689"/>
+            <a:ext cx="20080542" cy="337690"/>
           </a:xfrm>
           <a:prstGeom prst="rect">
             <a:avLst/>
@@ -7835,7 +7897,7 @@
       </p:sp>
       <p:pic>
         <p:nvPicPr>
-          <p:cNvPr id="118" name="Imagen 4" descr="Imagen 4"/>
+          <p:cNvPr id="119" name="Imagen 4" descr="Imagen 4"/>
           <p:cNvPicPr>
             <a:picLocks noChangeAspect="1"/>
           </p:cNvPicPr>
@@ -7851,8 +7913,8 @@
         </p:blipFill>
         <p:spPr>
           <a:xfrm>
-            <a:off x="975993" y="2450583"/>
-            <a:ext cx="17366238" cy="8217418"/>
+            <a:off x="975993" y="2450582"/>
+            <a:ext cx="17366238" cy="8217419"/>
           </a:xfrm>
           <a:prstGeom prst="rect">
             <a:avLst/>
@@ -7897,14 +7959,14 @@
       </p:grpSpPr>
       <p:sp>
         <p:nvSpPr>
-          <p:cNvPr id="120" name="object 2"/>
+          <p:cNvPr id="121" name="object 2"/>
           <p:cNvSpPr/>
           <p:nvPr/>
         </p:nvSpPr>
         <p:spPr>
           <a:xfrm>
             <a:off x="15705" y="2340242"/>
-            <a:ext cx="20080542" cy="636110"/>
+            <a:ext cx="20080542" cy="636111"/>
           </a:xfrm>
           <a:prstGeom prst="rect">
             <a:avLst/>
@@ -7933,7 +7995,7 @@
       </p:sp>
       <p:sp>
         <p:nvSpPr>
-          <p:cNvPr id="121" name="object 3"/>
+          <p:cNvPr id="122" name="object 3"/>
           <p:cNvSpPr txBox="1"/>
           <p:nvPr>
             <p:ph type="title"/>
@@ -7942,7 +8004,7 @@
         <p:spPr>
           <a:xfrm>
             <a:off x="975994" y="1179945"/>
-            <a:ext cx="8140066" cy="1026797"/>
+            <a:ext cx="8140066" cy="1026798"/>
           </a:xfrm>
           <a:prstGeom prst="rect">
             <a:avLst/>
@@ -7987,21 +8049,21 @@
       </p:sp>
       <p:grpSp>
         <p:nvGrpSpPr>
-          <p:cNvPr id="124" name="object 14"/>
+          <p:cNvPr id="125" name="object 14"/>
           <p:cNvGrpSpPr/>
           <p:nvPr/>
         </p:nvGrpSpPr>
         <p:grpSpPr>
           <a:xfrm>
-            <a:off x="15703" y="5497214"/>
-            <a:ext cx="20080549" cy="494754"/>
-            <a:chOff x="0" y="0"/>
-            <a:chExt cx="20080547" cy="494752"/>
+            <a:off x="15702" y="5497213"/>
+            <a:ext cx="20080552" cy="494757"/>
+            <a:chOff x="0" y="-1"/>
+            <a:chExt cx="20080551" cy="494755"/>
           </a:xfrm>
         </p:grpSpPr>
         <p:pic>
           <p:nvPicPr>
-            <p:cNvPr id="122" name="object 15" descr="object 15"/>
+            <p:cNvPr id="123" name="object 15" descr="object 15"/>
             <p:cNvPicPr>
               <a:picLocks noChangeAspect="1"/>
             </p:cNvPicPr>
@@ -8018,7 +8080,7 @@
           <p:spPr>
             <a:xfrm>
               <a:off x="6266826" y="15706"/>
-              <a:ext cx="5465806" cy="471194"/>
+              <a:ext cx="5465808" cy="471196"/>
             </a:xfrm>
             <a:prstGeom prst="rect">
               <a:avLst/>
@@ -8032,14 +8094,14 @@
         </p:pic>
         <p:sp>
           <p:nvSpPr>
-            <p:cNvPr id="123" name="object 16"/>
+            <p:cNvPr id="124" name="object 16"/>
             <p:cNvSpPr/>
             <p:nvPr/>
           </p:nvSpPr>
           <p:spPr>
             <a:xfrm>
-              <a:off x="-1" y="-1"/>
-              <a:ext cx="20080549" cy="494754"/>
+              <a:off x="-1" y="-2"/>
+              <a:ext cx="20080552" cy="494757"/>
             </a:xfrm>
             <a:prstGeom prst="rect">
               <a:avLst/>
@@ -8073,14 +8135,14 @@
       </p:grpSp>
       <p:sp>
         <p:nvSpPr>
-          <p:cNvPr id="125" name="object 19"/>
+          <p:cNvPr id="126" name="object 19"/>
           <p:cNvSpPr/>
           <p:nvPr/>
         </p:nvSpPr>
         <p:spPr>
           <a:xfrm>
             <a:off x="15705" y="7020728"/>
-            <a:ext cx="20080542" cy="337689"/>
+            <a:ext cx="20080542" cy="337690"/>
           </a:xfrm>
           <a:prstGeom prst="rect">
             <a:avLst/>
@@ -8109,14 +8171,14 @@
       </p:sp>
       <p:sp>
         <p:nvSpPr>
-          <p:cNvPr id="126" name="object 20"/>
+          <p:cNvPr id="127" name="object 20"/>
           <p:cNvSpPr/>
           <p:nvPr/>
         </p:nvSpPr>
         <p:spPr>
           <a:xfrm>
             <a:off x="15705" y="7491917"/>
-            <a:ext cx="20080542" cy="337689"/>
+            <a:ext cx="20080542" cy="337690"/>
           </a:xfrm>
           <a:prstGeom prst="rect">
             <a:avLst/>
@@ -8145,7 +8207,7 @@
       </p:sp>
       <p:pic>
         <p:nvPicPr>
-          <p:cNvPr id="127" name="Imagen 2" descr="Imagen 2"/>
+          <p:cNvPr id="128" name="Imagen 2" descr="Imagen 2"/>
           <p:cNvPicPr>
             <a:picLocks noChangeAspect="1"/>
           </p:cNvPicPr>
@@ -8207,14 +8269,14 @@
       </p:grpSpPr>
       <p:sp>
         <p:nvSpPr>
-          <p:cNvPr id="129" name="object 2"/>
+          <p:cNvPr id="130" name="object 2"/>
           <p:cNvSpPr/>
           <p:nvPr/>
         </p:nvSpPr>
         <p:spPr>
           <a:xfrm>
             <a:off x="15705" y="2340242"/>
-            <a:ext cx="20080542" cy="636110"/>
+            <a:ext cx="20080542" cy="636111"/>
           </a:xfrm>
           <a:prstGeom prst="rect">
             <a:avLst/>
@@ -8243,7 +8305,7 @@
       </p:sp>
       <p:sp>
         <p:nvSpPr>
-          <p:cNvPr id="130" name="object 3"/>
+          <p:cNvPr id="131" name="object 3"/>
           <p:cNvSpPr txBox="1"/>
           <p:nvPr>
             <p:ph type="title"/>
@@ -8252,7 +8314,7 @@
         <p:spPr>
           <a:xfrm>
             <a:off x="975994" y="1179945"/>
-            <a:ext cx="8140066" cy="1026797"/>
+            <a:ext cx="8140066" cy="1026798"/>
           </a:xfrm>
           <a:prstGeom prst="rect">
             <a:avLst/>
@@ -8297,21 +8359,21 @@
       </p:sp>
       <p:grpSp>
         <p:nvGrpSpPr>
-          <p:cNvPr id="133" name="object 14"/>
+          <p:cNvPr id="134" name="object 14"/>
           <p:cNvGrpSpPr/>
           <p:nvPr/>
         </p:nvGrpSpPr>
         <p:grpSpPr>
           <a:xfrm>
-            <a:off x="15703" y="5497214"/>
-            <a:ext cx="20080549" cy="494754"/>
-            <a:chOff x="0" y="0"/>
-            <a:chExt cx="20080547" cy="494752"/>
+            <a:off x="15702" y="5497213"/>
+            <a:ext cx="20080552" cy="494757"/>
+            <a:chOff x="0" y="-1"/>
+            <a:chExt cx="20080551" cy="494755"/>
           </a:xfrm>
         </p:grpSpPr>
         <p:pic>
           <p:nvPicPr>
-            <p:cNvPr id="131" name="object 15" descr="object 15"/>
+            <p:cNvPr id="132" name="object 15" descr="object 15"/>
             <p:cNvPicPr>
               <a:picLocks noChangeAspect="1"/>
             </p:cNvPicPr>
@@ -8328,7 +8390,7 @@
           <p:spPr>
             <a:xfrm>
               <a:off x="6266826" y="15706"/>
-              <a:ext cx="5465806" cy="471194"/>
+              <a:ext cx="5465808" cy="471196"/>
             </a:xfrm>
             <a:prstGeom prst="rect">
               <a:avLst/>
@@ -8342,14 +8404,14 @@
         </p:pic>
         <p:sp>
           <p:nvSpPr>
-            <p:cNvPr id="132" name="object 16"/>
+            <p:cNvPr id="133" name="object 16"/>
             <p:cNvSpPr/>
             <p:nvPr/>
           </p:nvSpPr>
           <p:spPr>
             <a:xfrm>
-              <a:off x="-1" y="-1"/>
-              <a:ext cx="20080549" cy="494754"/>
+              <a:off x="-1" y="-2"/>
+              <a:ext cx="20080552" cy="494757"/>
             </a:xfrm>
             <a:prstGeom prst="rect">
               <a:avLst/>
@@ -8383,14 +8445,14 @@
       </p:grpSp>
       <p:sp>
         <p:nvSpPr>
-          <p:cNvPr id="134" name="object 19"/>
+          <p:cNvPr id="135" name="object 19"/>
           <p:cNvSpPr/>
           <p:nvPr/>
         </p:nvSpPr>
         <p:spPr>
           <a:xfrm>
             <a:off x="15705" y="7020728"/>
-            <a:ext cx="20080542" cy="337689"/>
+            <a:ext cx="20080542" cy="337690"/>
           </a:xfrm>
           <a:prstGeom prst="rect">
             <a:avLst/>
@@ -8419,14 +8481,14 @@
       </p:sp>
       <p:sp>
         <p:nvSpPr>
-          <p:cNvPr id="135" name="object 20"/>
+          <p:cNvPr id="136" name="object 20"/>
           <p:cNvSpPr/>
           <p:nvPr/>
         </p:nvSpPr>
         <p:spPr>
           <a:xfrm>
             <a:off x="15705" y="7491917"/>
-            <a:ext cx="20080542" cy="337689"/>
+            <a:ext cx="20080542" cy="337690"/>
           </a:xfrm>
           <a:prstGeom prst="rect">
             <a:avLst/>
@@ -8455,7 +8517,7 @@
       </p:sp>
       <p:pic>
         <p:nvPicPr>
-          <p:cNvPr id="136" name="Imagen 3" descr="Imagen 3"/>
+          <p:cNvPr id="137" name="Imagen 3" descr="Imagen 3"/>
           <p:cNvPicPr>
             <a:picLocks noChangeAspect="1"/>
           </p:cNvPicPr>

</xml_diff>